<commit_message>
rozšírenie o suplované vyučovanie SRWE
</commit_message>
<xml_diff>
--- a/ITN_Module_17.pptx
+++ b/ITN_Module_17.pptx
@@ -255,7 +255,7 @@
 <file path=ppt/revisionInfo.xml><?xml version="1.0" encoding="utf-8"?>
 <p1510:revInfo xmlns:a="http://schemas.openxmlformats.org/drawingml/2006/main" xmlns:r="http://schemas.openxmlformats.org/officeDocument/2006/relationships" xmlns:p1510="http://schemas.microsoft.com/office/powerpoint/2015/10/main">
   <p1510:revLst>
-    <p1510:client id="{8651D787-E022-8246-9ED5-5D32C59AA605}" v="2" dt="2022-04-27T11:34:32.065"/>
+    <p1510:client id="{B74AC9AB-FD8F-28A8-F6FA-C0AA2EC052CC}" v="15" dt="2026-04-21T05:46:43.381"/>
   </p1510:revLst>
 </p1510:revInfo>
 </file>
@@ -263,180 +263,27 @@
 <file path=ppt/changesInfos/changesInfo1.xml><?xml version="1.0" encoding="utf-8"?>
 <pc:chgInfo xmlns:a="http://schemas.openxmlformats.org/drawingml/2006/main" xmlns:r="http://schemas.openxmlformats.org/officeDocument/2006/relationships" xmlns:ac="http://schemas.microsoft.com/office/drawing/2013/main/command" xmlns:pc="http://schemas.microsoft.com/office/powerpoint/2013/main/command">
   <pc:docChgLst>
-    <pc:chgData name="Július Baráth" userId="e650c4ab-697e-4750-bd58-c1531aabce95" providerId="ADAL" clId="{8651D787-E022-8246-9ED5-5D32C59AA605}"/>
-    <pc:docChg chg="custSel modSld">
-      <pc:chgData name="Július Baráth" userId="e650c4ab-697e-4750-bd58-c1531aabce95" providerId="ADAL" clId="{8651D787-E022-8246-9ED5-5D32C59AA605}" dt="2022-04-27T11:34:51.429" v="29" actId="1076"/>
+    <pc:chgData name="Baráth, Július" userId="S::julius.barath@aos.sk::aebde9b9-dccc-4475-a9ac-c05e78323d7a" providerId="AD" clId="Web-{B74AC9AB-FD8F-28A8-F6FA-C0AA2EC052CC}"/>
+    <pc:docChg chg="modSld">
+      <pc:chgData name="Baráth, Július" userId="S::julius.barath@aos.sk::aebde9b9-dccc-4475-a9ac-c05e78323d7a" providerId="AD" clId="Web-{B74AC9AB-FD8F-28A8-F6FA-C0AA2EC052CC}" dt="2026-04-21T05:46:43.381" v="14" actId="20577"/>
       <pc:docMkLst>
         <pc:docMk/>
       </pc:docMkLst>
-      <pc:sldChg chg="modSp mod">
-        <pc:chgData name="Július Baráth" userId="e650c4ab-697e-4750-bd58-c1531aabce95" providerId="ADAL" clId="{8651D787-E022-8246-9ED5-5D32C59AA605}" dt="2022-04-27T11:28:07.736" v="23" actId="20577"/>
+      <pc:sldChg chg="modSp">
+        <pc:chgData name="Baráth, Július" userId="S::julius.barath@aos.sk::aebde9b9-dccc-4475-a9ac-c05e78323d7a" providerId="AD" clId="Web-{B74AC9AB-FD8F-28A8-F6FA-C0AA2EC052CC}" dt="2026-04-21T05:46:43.381" v="14" actId="20577"/>
         <pc:sldMkLst>
           <pc:docMk/>
-          <pc:sldMk cId="1680069717" sldId="1150"/>
+          <pc:sldMk cId="3943937825" sldId="1108"/>
         </pc:sldMkLst>
         <pc:spChg chg="mod">
-          <ac:chgData name="Július Baráth" userId="e650c4ab-697e-4750-bd58-c1531aabce95" providerId="ADAL" clId="{8651D787-E022-8246-9ED5-5D32C59AA605}" dt="2022-04-27T11:28:07.736" v="23" actId="20577"/>
+          <ac:chgData name="Baráth, Július" userId="S::julius.barath@aos.sk::aebde9b9-dccc-4475-a9ac-c05e78323d7a" providerId="AD" clId="Web-{B74AC9AB-FD8F-28A8-F6FA-C0AA2EC052CC}" dt="2026-04-21T05:46:43.381" v="14" actId="20577"/>
           <ac:spMkLst>
             <pc:docMk/>
-            <pc:sldMk cId="1680069717" sldId="1150"/>
-            <ac:spMk id="4" creationId="{293C6751-32AF-45A8-BF93-DE124C4DE534}"/>
+            <pc:sldMk cId="3943937825" sldId="1108"/>
+            <ac:spMk id="5" creationId="{A64A5CE2-51F0-445D-8B69-BBA0D66EBA49}"/>
           </ac:spMkLst>
         </pc:spChg>
       </pc:sldChg>
-      <pc:sldChg chg="addSp delSp modSp mod">
-        <pc:chgData name="Július Baráth" userId="e650c4ab-697e-4750-bd58-c1531aabce95" providerId="ADAL" clId="{8651D787-E022-8246-9ED5-5D32C59AA605}" dt="2022-04-27T11:34:51.429" v="29" actId="1076"/>
-        <pc:sldMkLst>
-          <pc:docMk/>
-          <pc:sldMk cId="312038855" sldId="1167"/>
-        </pc:sldMkLst>
-        <pc:picChg chg="add mod">
-          <ac:chgData name="Július Baráth" userId="e650c4ab-697e-4750-bd58-c1531aabce95" providerId="ADAL" clId="{8651D787-E022-8246-9ED5-5D32C59AA605}" dt="2022-04-27T09:53:12.755" v="3" actId="1076"/>
-          <ac:picMkLst>
-            <pc:docMk/>
-            <pc:sldMk cId="312038855" sldId="1167"/>
-            <ac:picMk id="2" creationId="{920430C3-8F9F-DA4E-8BE3-75EFE41C69F6}"/>
-          </ac:picMkLst>
-        </pc:picChg>
-        <pc:picChg chg="add mod">
-          <ac:chgData name="Július Baráth" userId="e650c4ab-697e-4750-bd58-c1531aabce95" providerId="ADAL" clId="{8651D787-E022-8246-9ED5-5D32C59AA605}" dt="2022-04-27T11:34:51.429" v="29" actId="1076"/>
-          <ac:picMkLst>
-            <pc:docMk/>
-            <pc:sldMk cId="312038855" sldId="1167"/>
-            <ac:picMk id="4" creationId="{DDED132B-F776-1D45-93EA-20D68CCD4C60}"/>
-          </ac:picMkLst>
-        </pc:picChg>
-        <pc:picChg chg="del">
-          <ac:chgData name="Július Baráth" userId="e650c4ab-697e-4750-bd58-c1531aabce95" providerId="ADAL" clId="{8651D787-E022-8246-9ED5-5D32C59AA605}" dt="2022-04-27T09:53:02.888" v="0" actId="478"/>
-          <ac:picMkLst>
-            <pc:docMk/>
-            <pc:sldMk cId="312038855" sldId="1167"/>
-            <ac:picMk id="7" creationId="{EE795C2D-8259-4647-9ACD-26D36EE5517C}"/>
-          </ac:picMkLst>
-        </pc:picChg>
-      </pc:sldChg>
-    </pc:docChg>
-  </pc:docChgLst>
-  <pc:docChgLst>
-    <pc:chgData name="Július Baráth" userId="e650c4ab-697e-4750-bd58-c1531aabce95" providerId="ADAL" clId="{856BC706-B465-1A4D-9967-22236E640394}"/>
-    <pc:docChg chg="delSld">
-      <pc:chgData name="Július Baráth" userId="e650c4ab-697e-4750-bd58-c1531aabce95" providerId="ADAL" clId="{856BC706-B465-1A4D-9967-22236E640394}" dt="2020-01-20T11:58:12.639" v="14" actId="2696"/>
-      <pc:docMkLst>
-        <pc:docMk/>
-      </pc:docMkLst>
-      <pc:sldChg chg="del">
-        <pc:chgData name="Július Baráth" userId="e650c4ab-697e-4750-bd58-c1531aabce95" providerId="ADAL" clId="{856BC706-B465-1A4D-9967-22236E640394}" dt="2020-01-20T11:57:21.155" v="0" actId="2696"/>
-        <pc:sldMkLst>
-          <pc:docMk/>
-          <pc:sldMk cId="111192384" sldId="860"/>
-        </pc:sldMkLst>
-      </pc:sldChg>
-      <pc:sldChg chg="del">
-        <pc:chgData name="Július Baráth" userId="e650c4ab-697e-4750-bd58-c1531aabce95" providerId="ADAL" clId="{856BC706-B465-1A4D-9967-22236E640394}" dt="2020-01-20T11:58:12.638" v="13" actId="2696"/>
-        <pc:sldMkLst>
-          <pc:docMk/>
-          <pc:sldMk cId="3271745509" sldId="874"/>
-        </pc:sldMkLst>
-      </pc:sldChg>
-      <pc:sldChg chg="del">
-        <pc:chgData name="Július Baráth" userId="e650c4ab-697e-4750-bd58-c1531aabce95" providerId="ADAL" clId="{856BC706-B465-1A4D-9967-22236E640394}" dt="2020-01-20T11:58:04.038" v="6" actId="2696"/>
-        <pc:sldMkLst>
-          <pc:docMk/>
-          <pc:sldMk cId="410599242" sldId="957"/>
-        </pc:sldMkLst>
-      </pc:sldChg>
-      <pc:sldChg chg="del">
-        <pc:chgData name="Július Baráth" userId="e650c4ab-697e-4750-bd58-c1531aabce95" providerId="ADAL" clId="{856BC706-B465-1A4D-9967-22236E640394}" dt="2020-01-20T11:58:10.556" v="10" actId="2696"/>
-        <pc:sldMkLst>
-          <pc:docMk/>
-          <pc:sldMk cId="1531376889" sldId="1137"/>
-        </pc:sldMkLst>
-      </pc:sldChg>
-      <pc:sldChg chg="del">
-        <pc:chgData name="Július Baráth" userId="e650c4ab-697e-4750-bd58-c1531aabce95" providerId="ADAL" clId="{856BC706-B465-1A4D-9967-22236E640394}" dt="2020-01-20T11:57:47.028" v="2" actId="2696"/>
-        <pc:sldMkLst>
-          <pc:docMk/>
-          <pc:sldMk cId="858778739" sldId="1172"/>
-        </pc:sldMkLst>
-      </pc:sldChg>
-      <pc:sldChg chg="del">
-        <pc:chgData name="Július Baráth" userId="e650c4ab-697e-4750-bd58-c1531aabce95" providerId="ADAL" clId="{856BC706-B465-1A4D-9967-22236E640394}" dt="2020-01-20T11:57:48.780" v="3" actId="2696"/>
-        <pc:sldMkLst>
-          <pc:docMk/>
-          <pc:sldMk cId="489548829" sldId="1173"/>
-        </pc:sldMkLst>
-      </pc:sldChg>
-      <pc:sldChg chg="del">
-        <pc:chgData name="Július Baráth" userId="e650c4ab-697e-4750-bd58-c1531aabce95" providerId="ADAL" clId="{856BC706-B465-1A4D-9967-22236E640394}" dt="2020-01-20T11:58:01.396" v="4" actId="2696"/>
-        <pc:sldMkLst>
-          <pc:docMk/>
-          <pc:sldMk cId="1235419213" sldId="1183"/>
-        </pc:sldMkLst>
-      </pc:sldChg>
-      <pc:sldChg chg="del">
-        <pc:chgData name="Július Baráth" userId="e650c4ab-697e-4750-bd58-c1531aabce95" providerId="ADAL" clId="{856BC706-B465-1A4D-9967-22236E640394}" dt="2020-01-20T11:58:02.303" v="5" actId="2696"/>
-        <pc:sldMkLst>
-          <pc:docMk/>
-          <pc:sldMk cId="1782036442" sldId="1184"/>
-        </pc:sldMkLst>
-      </pc:sldChg>
-      <pc:sldChg chg="del">
-        <pc:chgData name="Július Baráth" userId="e650c4ab-697e-4750-bd58-c1531aabce95" providerId="ADAL" clId="{856BC706-B465-1A4D-9967-22236E640394}" dt="2020-01-20T11:58:06.313" v="7" actId="2696"/>
-        <pc:sldMkLst>
-          <pc:docMk/>
-          <pc:sldMk cId="4069828561" sldId="1185"/>
-        </pc:sldMkLst>
-      </pc:sldChg>
-      <pc:sldChg chg="del">
-        <pc:chgData name="Július Baráth" userId="e650c4ab-697e-4750-bd58-c1531aabce95" providerId="ADAL" clId="{856BC706-B465-1A4D-9967-22236E640394}" dt="2020-01-20T11:58:08.741" v="8" actId="2696"/>
-        <pc:sldMkLst>
-          <pc:docMk/>
-          <pc:sldMk cId="2446794932" sldId="1186"/>
-        </pc:sldMkLst>
-      </pc:sldChg>
-      <pc:sldChg chg="del">
-        <pc:chgData name="Július Baráth" userId="e650c4ab-697e-4750-bd58-c1531aabce95" providerId="ADAL" clId="{856BC706-B465-1A4D-9967-22236E640394}" dt="2020-01-20T11:58:09.664" v="9" actId="2696"/>
-        <pc:sldMkLst>
-          <pc:docMk/>
-          <pc:sldMk cId="436259101" sldId="1187"/>
-        </pc:sldMkLst>
-      </pc:sldChg>
-      <pc:sldChg chg="del">
-        <pc:chgData name="Július Baráth" userId="e650c4ab-697e-4750-bd58-c1531aabce95" providerId="ADAL" clId="{856BC706-B465-1A4D-9967-22236E640394}" dt="2020-01-20T11:58:11.121" v="11" actId="2696"/>
-        <pc:sldMkLst>
-          <pc:docMk/>
-          <pc:sldMk cId="51846859" sldId="1188"/>
-        </pc:sldMkLst>
-      </pc:sldChg>
-      <pc:sldChg chg="del">
-        <pc:chgData name="Július Baráth" userId="e650c4ab-697e-4750-bd58-c1531aabce95" providerId="ADAL" clId="{856BC706-B465-1A4D-9967-22236E640394}" dt="2020-01-20T11:58:11.653" v="12" actId="2696"/>
-        <pc:sldMkLst>
-          <pc:docMk/>
-          <pc:sldMk cId="19656539" sldId="1189"/>
-        </pc:sldMkLst>
-      </pc:sldChg>
-      <pc:sldChg chg="del">
-        <pc:chgData name="Július Baráth" userId="e650c4ab-697e-4750-bd58-c1531aabce95" providerId="ADAL" clId="{856BC706-B465-1A4D-9967-22236E640394}" dt="2020-01-20T11:57:39.026" v="1" actId="2696"/>
-        <pc:sldMkLst>
-          <pc:docMk/>
-          <pc:sldMk cId="1440878941" sldId="1194"/>
-        </pc:sldMkLst>
-      </pc:sldChg>
-      <pc:sldMasterChg chg="delSldLayout">
-        <pc:chgData name="Július Baráth" userId="e650c4ab-697e-4750-bd58-c1531aabce95" providerId="ADAL" clId="{856BC706-B465-1A4D-9967-22236E640394}" dt="2020-01-20T11:58:12.639" v="14" actId="2696"/>
-        <pc:sldMasterMkLst>
-          <pc:docMk/>
-          <pc:sldMasterMk cId="0" sldId="2147483700"/>
-        </pc:sldMasterMkLst>
-        <pc:sldLayoutChg chg="del">
-          <pc:chgData name="Július Baráth" userId="e650c4ab-697e-4750-bd58-c1531aabce95" providerId="ADAL" clId="{856BC706-B465-1A4D-9967-22236E640394}" dt="2020-01-20T11:58:12.639" v="14" actId="2696"/>
-          <pc:sldLayoutMkLst>
-            <pc:docMk/>
-            <pc:sldMasterMk cId="0" sldId="2147483700"/>
-            <pc:sldLayoutMk cId="2257996623" sldId="2147484029"/>
-          </pc:sldLayoutMkLst>
-        </pc:sldLayoutChg>
-      </pc:sldMasterChg>
     </pc:docChg>
   </pc:docChgLst>
 </pc:chgInfo>
@@ -524,7 +371,7 @@
           <a:p>
             <a:fld id="{136337D9-3022-3D41-8D8A-BDF2F3B0DD8E}" type="datetimeFigureOut">
               <a:rPr lang="en-US" smtClean="0"/>
-              <a:t>4/27/22</a:t>
+              <a:t>4/20/2026</a:t>
             </a:fld>
             <a:endParaRPr lang="en-US" dirty="0"/>
           </a:p>
@@ -32385,7 +32232,9 @@
           </a:xfrm>
         </p:spPr>
         <p:txBody>
-          <a:bodyPr/>
+          <a:bodyPr lIns="91420" tIns="45710" rIns="91420" bIns="45710" anchor="t">
+            <a:noAutofit/>
+          </a:bodyPr>
           <a:lstStyle/>
           <a:p>
             <a:pPr marL="285750" indent="-285750" algn="l">
@@ -32397,6 +32246,7 @@
                 <a:solidFill>
                   <a:srgbClr val="000000"/>
                 </a:solidFill>
+                <a:ea typeface="ＭＳ Ｐゴシック"/>
               </a:rPr>
               <a:t>The majority of businesses are small most of the business networks are also small.</a:t>
             </a:r>
@@ -32407,12 +32257,13 @@
               <a:buChar char="•"/>
             </a:pPr>
             <a:r>
-              <a:rPr lang="en-US" sz="1800" dirty="0">
+              <a:rPr lang="en-US" sz="1800">
                 <a:solidFill>
                   <a:srgbClr val="000000"/>
                 </a:solidFill>
+                <a:ea typeface="ＭＳ Ｐゴシック"/>
               </a:rPr>
-              <a:t>A small network design is usually simple.</a:t>
+              <a:t>A small network design is usually simple (10-50 nodes).</a:t>
             </a:r>
           </a:p>
           <a:p>
@@ -32439,6 +32290,7 @@
                 <a:solidFill>
                   <a:srgbClr val="000000"/>
                 </a:solidFill>
+                <a:ea typeface="ＭＳ Ｐゴシック"/>
               </a:rPr>
               <a:t>Large networks require an IT department to maintain, secure, and troubleshoot network devices and to protect organizational data. Small networks are managed by a local IT technician or by a contracted professional.</a:t>
             </a:r>

</xml_diff>